<commit_message>
lerning hub idea upfate
</commit_message>
<xml_diff>
--- a/06.00-idea/00.00-learning-hub/_assets/images.v2.pptx
+++ b/06.00-idea/00.00-learning-hub/_assets/images.v2.pptx
@@ -2634,7 +2634,7 @@
               <a:buNone/>
             </a:pPr>
             <a:r>
-              <a:rPr lang="en-US" sz="700" i="1" dirty="0">
+              <a:rPr lang="en-US" sz="700" i="1">
                 <a:solidFill>
                   <a:srgbClr val="6B7A92"/>
                 </a:solidFill>
@@ -2642,7 +2642,7 @@
                 <a:ea typeface="Calibri" pitchFamily="34" charset="-122"/>
                 <a:cs typeface="Calibri" pitchFamily="34" charset="-120"/>
               </a:rPr>
-              <a:t>what you meet, normalised into one corpus</a:t>
+              <a:t>what you meet — wherever you decide, any medium</a:t>
             </a:r>
             <a:endParaRPr lang="en-US" sz="700" dirty="0"/>
           </a:p>
@@ -3616,7 +3616,7 @@
               <a:buNone/>
             </a:pPr>
             <a:r>
-              <a:rPr lang="en-US" sz="800" i="1" dirty="0">
+              <a:rPr lang="en-US" sz="800" i="1">
                 <a:solidFill>
                   <a:srgbClr val="AFBEE0"/>
                 </a:solidFill>
@@ -3624,7 +3624,7 @@
                 <a:ea typeface="Calibri" pitchFamily="34" charset="-122"/>
                 <a:cs typeface="Calibri" pitchFamily="34" charset="-120"/>
               </a:rPr>
-              <a:t>one governed corpus — delivered live, kept current</a:t>
+              <a:t>your knowledge — many sources, one place to think</a:t>
             </a:r>
             <a:endParaRPr lang="en-US" sz="800" dirty="0"/>
           </a:p>
@@ -4965,7 +4965,7 @@
               <a:buNone/>
             </a:pPr>
             <a:r>
-              <a:rPr lang="en-US" sz="950" b="1" dirty="0">
+              <a:rPr lang="en-US" sz="950" b="1">
                 <a:solidFill>
                   <a:srgbClr val="FFFFFF"/>
                 </a:solidFill>
@@ -4976,7 +4976,7 @@
               <a:t>MULTI-SOURCE STORAGE</a:t>
             </a:r>
             <a:r>
-              <a:rPr lang="en-US" sz="750" dirty="0">
+              <a:rPr lang="en-US" sz="750">
                 <a:solidFill>
                   <a:srgbClr val="AFBEE0"/>
                 </a:solidFill>
@@ -4984,7 +4984,7 @@
                 <a:ea typeface="Trebuchet MS" pitchFamily="34" charset="-122"/>
                 <a:cs typeface="Trebuchet MS" pitchFamily="34" charset="-120"/>
               </a:rPr>
-              <a:t>   where the files reside — public and private, one corpus</a:t>
+              <a:t>   where the files reside — public and private, served as one</a:t>
             </a:r>
             <a:endParaRPr lang="en-US" sz="950" dirty="0"/>
           </a:p>

</xml_diff>